<commit_message>
Calendário: aulas passam a 16/09 → 05/10/2026
Todas as datas de aula deslocadas em 7 dias, mantendo seg/qua/sex e a
ordem das aulas. Atualizados cronograma.png, deck da Aula 1, checklist
de ambiente, materiais do aluno (ADRs datados) e prazo de entrega do
projeto final (05/10, 09:00 BRT).

Co-Authored-By: Claude Opus 5 <noreply@anthropic.com>
</commit_message>
<xml_diff>
--- a/plano-de-aulas/aula-01-slides.pptx
+++ b/plano-de-aulas/aula-01-slides.pptx
@@ -4643,47 +4643,47 @@
           <a:lstStyle/>
           <a:p>
             <a:r>
-              <a:t>09/09 Abertura + Ágil na prática</a:t>
-            </a:r>
-          </a:p>
-          <a:p>
-            <a:r>
-              <a:t>11/09 Pirâmide de testes + o que é arquitetura</a:t>
-            </a:r>
-          </a:p>
-          <a:p>
-            <a:r>
-              <a:t>14/09 Arquitetura monolítica</a:t>
-            </a:r>
-          </a:p>
-          <a:p>
-            <a:r>
-              <a:t>16/09 SOA × REST e contratos</a:t>
-            </a:r>
-          </a:p>
-          <a:p>
-            <a:r>
-              <a:t>18/09 Quebrando o monólito</a:t>
-            </a:r>
-          </a:p>
-          <a:p>
-            <a:r>
-              <a:t>21/09 Discovery + OpenFeign</a:t>
-            </a:r>
-          </a:p>
-          <a:p>
-            <a:r>
-              <a:t>23/09 Clean Code + SOLID</a:t>
-            </a:r>
-          </a:p>
-          <a:p>
-            <a:r>
-              <a:t>25/09 Design Patterns</a:t>
-            </a:r>
-          </a:p>
-          <a:p>
-            <a:r>
-              <a:t>28/09 Apresentações dos projetos + devolutiva</a:t>
+              <a:t>16/09 Abertura + Ágil na prática</a:t>
+            </a:r>
+          </a:p>
+          <a:p>
+            <a:r>
+              <a:t>18/09 Pirâmide de testes + o que é arquitetura</a:t>
+            </a:r>
+          </a:p>
+          <a:p>
+            <a:r>
+              <a:t>21/09 Arquitetura monolítica</a:t>
+            </a:r>
+          </a:p>
+          <a:p>
+            <a:r>
+              <a:t>23/09 SOA × REST e contratos</a:t>
+            </a:r>
+          </a:p>
+          <a:p>
+            <a:r>
+              <a:t>25/09 Quebrando o monólito</a:t>
+            </a:r>
+          </a:p>
+          <a:p>
+            <a:r>
+              <a:t>28/09 Discovery + OpenFeign</a:t>
+            </a:r>
+          </a:p>
+          <a:p>
+            <a:r>
+              <a:t>30/09 Clean Code + SOLID</a:t>
+            </a:r>
+          </a:p>
+          <a:p>
+            <a:r>
+              <a:t>02/10 Design Patterns</a:t>
+            </a:r>
+          </a:p>
+          <a:p>
+            <a:r>
+              <a:t>05/10 Apresentações dos projetos + devolutiva</a:t>
             </a:r>
           </a:p>
         </p:txBody>
@@ -4868,7 +4868,7 @@
           </a:p>
           <a:p>
             <a:r>
-              <a:t>Desenvolvido na 2ª metade das aulas; apresentação em 28/09</a:t>
+              <a:t>Desenvolvido na 2ª metade das aulas; apresentação em 05/10</a:t>
             </a:r>
           </a:p>
           <a:p>

</xml_diff>